<commit_message>
docs: record fresh local rebuild results
</commit_message>
<xml_diff>
--- a/docs/submission/Warden-CCD-Project-Presentation.pptx
+++ b/docs/submission/Warden-CCD-Project-Presentation.pptx
@@ -782,7 +782,7 @@
           <a:p>
             <a:r>
               <a:rPr lang="en-US" dirty="0"/>
-              <a:t>E6 met its target: eleven of twelve local rebuilds succeeded; five Azure rebuilds succeeded from an empty subscription. Four failed Azure attempts are kept and explained in the ledger. A long Azure bootstrap attempt took 57 minutes; the others were near 22 minutes.</a:t>
+              <a:t>E6 met its target: twelve of thirteen local rebuilds succeeded; five Azure rebuilds succeeded from an empty subscription. Four failed Azure attempts are kept and explained in the ledger. The 2026-10-27 fresh local run took 869 seconds; 23 of 23 applications became Synced/Healthy and all four services returned HTTP 200. Its ledger row marks the worktrees dirty because local instruction files were untracked.</a:t>
             </a:r>
             <a:endParaRPr lang="en-US" dirty="0"/>
           </a:p>
@@ -5469,7 +5469,7 @@
                 <a:ea typeface="Cambria" pitchFamily="34" charset="-122"/>
                 <a:cs typeface="Cambria" pitchFamily="34" charset="-120"/>
               </a:rPr>
-              <a:t>11 / 12</a:t>
+              <a:t>12 / 13</a:t>
             </a:r>
             <a:endParaRPr lang="en-US" sz="4200" dirty="0"/>
           </a:p>
@@ -5551,7 +5551,7 @@
                 <a:ea typeface="Calibri" pitchFamily="34" charset="-122"/>
                 <a:cs typeface="Calibri" pitchFamily="34" charset="-120"/>
               </a:rPr>
-              <a:t>Median 14.9 min  ·  p90 24.2 min</a:t>
+              <a:t>Median 14.8 min  ·  p90 24.2 min</a:t>
             </a:r>
             <a:endParaRPr lang="en-US" sz="1400" dirty="0"/>
           </a:p>
@@ -7892,7 +7892,7 @@
                 <a:ea typeface="Calibri" pitchFamily="34" charset="-122"/>
                 <a:cs typeface="Calibri" pitchFamily="34" charset="-120"/>
               </a:rPr>
-              <a:t>Record the four scenarios, rehearse a fresh local rebuild, update the open-items slide and obtain supervisor review.</a:t>
+              <a:t>Record the four scenes, update this slide on presentation day and obtain supervisor review. The fresh local rebuild rehearsal passed.</a:t>
             </a:r>
             <a:endParaRPr lang="en-US" sz="1300" dirty="0"/>
           </a:p>

</xml_diff>